<commit_message>
Add Day 5 workshop content
Co-authored-by: Copilot App <223556219+Copilot@users.noreply.github.com>
</commit_message>
<xml_diff>
--- a/decks/day1/module-1-landscape.pptx
+++ b/decks/day1/module-1-landscape.pptx
@@ -891,9 +891,9 @@
               <a:t>• Preview the 5-day arc in 60 seconds
 • Days 1–3 build on the same 'docs assistant' reference project
 • Day 4 turns the single agent into a multi-agent workflow
-• Day 5 covers production + capstone kickoff
+• Day 5 covers production evidence, Foundry Toolkit, and capstone kickoff
 • Every day maps to the four-layer stack (Module 5)
-• Post-workshop: capstone project reviewed 1:1</a:t>
+• Post-workshop: teams present at a shared capstone demo day</a:t>
             </a:r>
             <a:endParaRPr lang="en-US" dirty="0"/>
           </a:p>
@@ -4277,7 +4277,7 @@
                           <a:ea typeface="Calibri" pitchFamily="34" charset="-122"/>
                           <a:cs typeface="Calibri" pitchFamily="34" charset="-120"/>
                         </a:rPr>
-                        <a:t>Production concerns; capstone project kickoff</a:t>
+                        <a:t>Production readiness, Foundry Toolkit, and capstone kickoff</a:t>
                       </a:r>
                       <a:endParaRPr lang="en-US" sz="1300" dirty="0">
                         <a:latin typeface="Calibri" charset="0"/>

</xml_diff>